<commit_message>
fix profil extractor example fallback, unify example profils
</commit_message>
<xml_diff>
--- a/examples/templates/de/cv_template.pptx
+++ b/examples/templates/de/cv_template.pptx
@@ -6413,7 +6413,7 @@
                 <a:uFillTx/>
                 <a:latin typeface="Calibri"/>
               </a:rPr>
-              <a:t>Johannes Schmidt</a:t>
+              <a:t>Pepito Perez</a:t>
             </a:r>
             <a:endParaRPr lang="de-DE" sz="1400" b="0" u="none" strike="noStrike">
               <a:solidFill>
@@ -6439,7 +6439,7 @@
                 <a:uFillTx/>
                 <a:latin typeface="Calibri"/>
               </a:rPr>
-              <a:t>Musterstraße 42, 10115 Berlin, Deutschland</a:t>
+              <a:t>742 Maple Avenue, Apt 3B, Cambridge, MA 02139, USA</a:t>
             </a:r>
             <a:endParaRPr lang="de-DE" sz="1100" b="0" u="none" strike="noStrike">
               <a:solidFill>
@@ -6465,7 +6465,7 @@
                 <a:uFillTx/>
                 <a:latin typeface="Calibri"/>
               </a:rPr>
-              <a:t>johannes.schmidt@beispiel.de  |  +49 (30) 9876-5432</a:t>
+              <a:t>pepito.perez@example.com  |  +1 (555) 123-4567</a:t>
             </a:r>
             <a:endParaRPr lang="de-DE" sz="1100" b="0" u="none" strike="noStrike">
               <a:solidFill>
@@ -6491,7 +6491,7 @@
                 <a:uFillTx/>
                 <a:latin typeface="Calibri"/>
               </a:rPr>
-              <a:t>linkedin.com/in/johannesschmidt-maschinenbau</a:t>
+              <a:t>linkedin.com/in/johnsmith-mech</a:t>
             </a:r>
             <a:endParaRPr lang="de-DE" sz="1100" b="0" u="none" strike="noStrike">
               <a:solidFill>
@@ -6898,7 +6898,7 @@
                 <a:uFillTx/>
                 <a:latin typeface="Calibri"/>
               </a:rPr>
-              <a:t>Wissenschaftlicher Mitarbeiter - TU Berlin, Lehrstuhl für Erneuerbare Energien &amp; CFD  |  Berlin, Deutschland  |  Okt 2022 - Sep 2023</a:t>
+              <a:t>Graduate Research Assistant - MIT Renewable Energy CFD Lab  |  Cambridge, MA, USA  |  Sep 2022 - Jun 2023</a:t>
             </a:r>
             <a:endParaRPr lang="de-DE" sz="1100" b="0" u="none" strike="noStrike">
               <a:solidFill>
@@ -6955,7 +6955,7 @@
                 <a:uFillTx/>
                 <a:latin typeface="Calibri"/>
               </a:rPr>
-              <a:t>Entwicklung hochauflösender Actuator-Line-CFD-Modelle für VAWTs mit ANSYS Fluent.</a:t>
+              <a:t>Developed high-fidelity actuator-line CFD models for vertical-axis wind turbines using ANSYS Fluent.</a:t>
             </a:r>
             <a:endParaRPr lang="de-DE" sz="1000" b="0" u="none" strike="noStrike">
               <a:solidFill>
@@ -7012,7 +7012,7 @@
                 <a:uFillTx/>
                 <a:latin typeface="Calibri"/>
               </a:rPr>
-              <a:t>Simulation von Nachlaufinteraktionen in Arrays bis zu 12 Turbinen; 15% Leistungsdichtesteigerung.</a:t>
+              <a:t>Simulated wake interactions in arrays up to 12 turbines, improving array power density by 15%.</a:t>
             </a:r>
             <a:endParaRPr lang="de-DE" sz="1000" b="0" u="none" strike="noStrike">
               <a:solidFill>
@@ -7069,7 +7069,7 @@
                 <a:uFillTx/>
                 <a:latin typeface="Calibri"/>
               </a:rPr>
-              <a:t>Automatisierung parametrischer Workflows mit MATLAB/Python, 40% Zeitersparnis.</a:t>
+              <a:t>Automated parametric sweep workflows with MATLAB/Python, reducing setup time by 40%.</a:t>
             </a:r>
             <a:endParaRPr lang="de-DE" sz="1000" b="0" u="none" strike="noStrike">
               <a:solidFill>
@@ -7126,7 +7126,7 @@
                 <a:uFillTx/>
                 <a:latin typeface="Calibri"/>
               </a:rPr>
-              <a:t>CFD-Ingenieur-Praktikant - Siemens Energy  |  Berlin / Mülheim an der Ruhr, Deutschland  |  Jun 2022 - Aug 2022</a:t>
+              <a:t>CFD Engineering Intern - Siemens Energy  |  Orlando, FL, USA  |  Jun 2022 - Aug 2022</a:t>
             </a:r>
             <a:endParaRPr lang="de-DE" sz="1100" b="0" u="none" strike="noStrike">
               <a:solidFill>
@@ -7183,7 +7183,7 @@
                 <a:uFillTx/>
                 <a:latin typeface="Calibri"/>
               </a:rPr>
-              <a:t>Durchführung stationärer und transienter CFD-Simulationen von Gasturbinen-Kühlkanälen.</a:t>
+              <a:t>Performed steady-state and transient CFD simulations of gas turbine cooling channels.</a:t>
             </a:r>
             <a:endParaRPr lang="de-DE" sz="1000" b="0" u="none" strike="noStrike">
               <a:solidFill>
@@ -7240,7 +7240,7 @@
                 <a:uFillTx/>
                 <a:latin typeface="Calibri"/>
               </a:rPr>
-              <a:t>Validierung der Ergebnisse anhand experimenteller Daten; mittlere Abweichung &lt;5%.</a:t>
+              <a:t>Validated simulation results against experimental data with &lt;5% average deviation.</a:t>
             </a:r>
             <a:endParaRPr lang="de-DE" sz="1000" b="0" u="none" strike="noStrike">
               <a:solidFill>
@@ -7297,7 +7297,7 @@
                 <a:uFillTx/>
                 <a:latin typeface="Calibri"/>
               </a:rPr>
-              <a:t>Konstruktionspraktikant - Nordex SE  |  Hamburg, Deutschland  |  Jun 2020 - Aug 2020</a:t>
+              <a:t>Mechanical Design Intern - Vestas Wind Systems  |  Portland, OR, USA  |  Jun 2020 - Aug 2020</a:t>
             </a:r>
             <a:endParaRPr lang="de-DE" sz="1100" b="0" u="none" strike="noStrike">
               <a:solidFill>
@@ -7354,7 +7354,7 @@
                 <a:uFillTx/>
                 <a:latin typeface="Calibri"/>
               </a:rPr>
-              <a:t>Unterstützung bei der Strukturanalyse von Gondelkomponenten mit ANSYS Mechanical.</a:t>
+              <a:t>Assisted in structural analysis of wind turbine nacelle components using ANSYS Mechanical.</a:t>
             </a:r>
             <a:endParaRPr lang="de-DE" sz="1000" b="0" u="none" strike="noStrike">
               <a:solidFill>
@@ -7411,7 +7411,7 @@
                 <a:uFillTx/>
                 <a:latin typeface="Calibri"/>
               </a:rPr>
-              <a:t>Erstellung von 3D-CAD-Modellen von Antriebsstrang-Baugruppen in SolidWorks.</a:t>
+              <a:t>Designed 3D CAD models of drivetrain sub-assemblies in SolidWorks.</a:t>
             </a:r>
             <a:endParaRPr lang="de-DE" sz="1000" b="0" u="none" strike="noStrike">
               <a:solidFill>
@@ -7525,7 +7525,7 @@
                 <a:uFillTx/>
                 <a:latin typeface="Calibri"/>
               </a:rPr>
-              <a:t>Master of Science im Maschinenbau (M.Sc.) - Technische Universität Berlin - Okt 2021 - Sep 2023</a:t>
+              <a:t>Master of Science in Mechanical Engineering - Massachusetts Institute of Technology (MIT) - Sep 2021 - Jun 2023</a:t>
             </a:r>
             <a:endParaRPr lang="de-DE" sz="1100" b="0" u="none" strike="noStrike">
               <a:solidFill>
@@ -7639,7 +7639,7 @@
                 <a:uFillTx/>
                 <a:latin typeface="Calibri"/>
               </a:rPr>
-              <a:t>Bachelor of Science im Maschinenbau (B.Sc.) - RWTH Aachen - Okt 2016 - Sep 2020</a:t>
+              <a:t>Bachelor of Science in Mechanical Engineering - University of Michigan - Sep 2016 - May 2020</a:t>
             </a:r>
             <a:endParaRPr lang="de-DE" sz="1100" b="0" u="none" strike="noStrike">
               <a:solidFill>
@@ -7810,7 +7810,7 @@
                 <a:uFillTx/>
                 <a:latin typeface="Calibri"/>
               </a:rPr>
-              <a:t>Experte in ANSYS Fluent, Python, MATLAB und SolidWorks</a:t>
+              <a:t>Expert in ANSYS Fluent, Python, MATLAB, and SolidWorks</a:t>
             </a:r>
             <a:endParaRPr lang="de-DE" sz="1000" b="0" u="none" strike="noStrike">
               <a:solidFill>
@@ -7867,7 +7867,7 @@
                 <a:uFillTx/>
                 <a:latin typeface="Calibri"/>
               </a:rPr>
-              <a:t>Sprachen: Deutsch (Muttersprache), Englisch (Verhandlungssicher C1)</a:t>
+              <a:t>Languages: English (Native), German (Intermediate B1)</a:t>
             </a:r>
             <a:endParaRPr lang="de-DE" sz="1000" b="0" u="none" strike="noStrike">
               <a:solidFill>
@@ -7924,7 +7924,7 @@
                 <a:uFillTx/>
                 <a:latin typeface="Calibri"/>
               </a:rPr>
-              <a:t>Optimierung der Anordnung von VAWTs (Masterarbeit)</a:t>
+              <a:t>VAWT Array Wake Optimization (Master's Thesis)</a:t>
             </a:r>
             <a:endParaRPr lang="de-DE" sz="1000" b="0" u="none" strike="noStrike">
               <a:solidFill>
@@ -7981,7 +7981,7 @@
                 <a:uFillTx/>
                 <a:latin typeface="Calibri"/>
               </a:rPr>
-              <a:t>Solarbetriebene Wasserpumpe für ländliche Gemeinden (Bachelorarbeit)</a:t>
+              <a:t>Solar-Powered Water Pump for Rural Communities (B.Sc. Capstone)</a:t>
             </a:r>
             <a:endParaRPr lang="de-DE" sz="1000" b="0" u="none" strike="noStrike">
               <a:solidFill>

</xml_diff>